<commit_message>
Deck: follow plain SIH template, no app logo
Co-Authored-By: Claude Opus 5.5 <noreply@anthropic.com>
Claude-Session: https://claude.ai/code/session_01GaKx3zyvideZzrF32J24P4
</commit_message>
<xml_diff>
--- a/docs/COOLKATS_187666_SIH2026_eRTMAC-NWIS.pptx
+++ b/docs/COOLKATS_187666_SIH2026_eRTMAC-NWIS.pptx
@@ -3639,75 +3639,29 @@
       </p:sp>
       <p:pic>
         <p:nvPicPr>
-          <p:cNvPr id="14" name="Picture 13" descr="logo.png"/>
+          <p:cNvPr id="14" name="Picture 13" descr="tpl_2_0_X13.png"/>
           <p:cNvPicPr>
             <a:picLocks noChangeAspect="1"/>
           </p:cNvPicPr>
           <p:nvPr/>
         </p:nvPicPr>
         <p:blipFill>
-          <a:blip r:embed="rId3"/>
+          <a:blip r:embed="rId2"/>
+          <a:srcRect r="58000"/>
           <a:stretch>
             <a:fillRect/>
           </a:stretch>
         </p:blipFill>
         <p:spPr>
           <a:xfrm>
-            <a:off x="13652500" y="3492500"/>
-            <a:ext cx="2921000" cy="2921000"/>
+            <a:off x="12827000" y="2540000"/>
+            <a:ext cx="4343400" cy="4889500"/>
           </a:xfrm>
           <a:prstGeom prst="rect">
             <a:avLst/>
           </a:prstGeom>
         </p:spPr>
       </p:pic>
-      <p:sp>
-        <p:nvSpPr>
-          <p:cNvPr id="15" name="TextBox 14"/>
-          <p:cNvSpPr txBox="1"/>
-          <p:nvPr/>
-        </p:nvSpPr>
-        <p:spPr>
-          <a:xfrm>
-            <a:off x="12509500" y="6604000"/>
-            <a:ext cx="5207000" cy="1143000"/>
-          </a:xfrm>
-          <a:prstGeom prst="rect">
-            <a:avLst/>
-          </a:prstGeom>
-          <a:noFill/>
-        </p:spPr>
-        <p:txBody>
-          <a:bodyPr wrap="square" anchor="t" lIns="25400" rIns="25400" tIns="25400" bIns="25400">
-            <a:spAutoFit/>
-          </a:bodyPr>
-          <a:lstStyle/>
-          <a:p>
-            <a:pPr algn="ctr"/>
-            <a:r>
-              <a:rPr sz="3000" b="1" u="none">
-                <a:solidFill>
-                  <a:srgbClr val="1E1E1E"/>
-                </a:solidFill>
-                <a:latin typeface="Georgia"/>
-              </a:rPr>
-              <a:t>eRTMAC NWIS</a:t>
-            </a:r>
-          </a:p>
-          <a:p>
-            <a:pPr algn="ctr"/>
-            <a:r>
-              <a:rPr sz="1700" b="0" u="none">
-                <a:solidFill>
-                  <a:srgbClr val="595959"/>
-                </a:solidFill>
-                <a:latin typeface="Arial"/>
-              </a:rPr>
-              <a:t>Nearby Wells Intelligence System</a:t>
-            </a:r>
-          </a:p>
-        </p:txBody>
-      </p:sp>
     </p:spTree>
   </p:cSld>
   <p:clrMapOvr>
@@ -3835,7 +3789,7 @@
                 </a:solidFill>
                 <a:latin typeface="Times New Roman"/>
               </a:rPr>
-              <a:t>eRTMAC NWIS</a:t>
+              <a:t>IDEA TITLE: eRTMAC NWIS</a:t>
             </a:r>
           </a:p>
         </p:txBody>
@@ -4468,7 +4422,7 @@
         <p:spPr>
           <a:xfrm>
             <a:off x="11239500" y="5588000"/>
-            <a:ext cx="4699000" cy="508000"/>
+            <a:ext cx="4826000" cy="508000"/>
           </a:xfrm>
           <a:prstGeom prst="rect">
             <a:avLst/>
@@ -4483,7 +4437,7 @@
           <a:p>
             <a:pPr algn="l"/>
             <a:r>
-              <a:rPr sz="2000" b="1" u="none">
+              <a:rPr sz="1900" b="1" u="none">
                 <a:solidFill>
                   <a:srgbClr val="1F4E8C"/>
                 </a:solidFill>
@@ -4492,13 +4446,13 @@
               <a:t>• </a:t>
             </a:r>
             <a:r>
-              <a:rPr sz="2000" b="1" u="sng">
+              <a:rPr sz="1900" b="1" u="sng">
                 <a:solidFill>
                   <a:srgbClr val="1F4E8C"/>
                 </a:solidFill>
                 <a:latin typeface="Arial"/>
               </a:rPr>
-              <a:t>Innovation &amp; uniqueness</a:t>
+              <a:t>Innovation and uniqueness</a:t>
             </a:r>
           </a:p>
         </p:txBody>
@@ -4960,7 +4914,7 @@
                 </a:solidFill>
                 <a:latin typeface="Arial"/>
               </a:rPr>
-              <a:t>Technologies used</a:t>
+              <a:t>Technologies to be used</a:t>
             </a:r>
           </a:p>
         </p:txBody>
@@ -5584,7 +5538,7 @@
                 </a:solidFill>
                 <a:latin typeface="Arial"/>
               </a:rPr>
-              <a:t>Methodology &amp; process (working prototype)</a:t>
+              <a:t>Methodology and process for implementation</a:t>
             </a:r>
           </a:p>
         </p:txBody>
@@ -6710,13 +6664,13 @@
           <a:p>
             <a:pPr algn="ctr"/>
             <a:r>
-              <a:rPr sz="2100" b="1" u="none">
+              <a:rPr sz="1800" b="1" u="none">
                 <a:solidFill>
                   <a:srgbClr val="FFFFFF"/>
                 </a:solidFill>
                 <a:latin typeface="Arial"/>
               </a:rPr>
-              <a:t>Feasibility of the idea</a:t>
+              <a:t>Analysis of the feasibility of the idea</a:t>
             </a:r>
           </a:p>
         </p:txBody>
@@ -6987,13 +6941,13 @@
           <a:p>
             <a:pPr algn="ctr"/>
             <a:r>
-              <a:rPr sz="2100" b="1" u="none">
+              <a:rPr sz="1800" b="1" u="none">
                 <a:solidFill>
                   <a:srgbClr val="FFFFFF"/>
                 </a:solidFill>
                 <a:latin typeface="Arial"/>
               </a:rPr>
-              <a:t>Potential challenges &amp; risks</a:t>
+              <a:t>Potential challenges and risks</a:t>
             </a:r>
           </a:p>
         </p:txBody>
@@ -7264,13 +7218,13 @@
           <a:p>
             <a:pPr algn="ctr"/>
             <a:r>
-              <a:rPr sz="2100" b="1" u="none">
+              <a:rPr sz="1800" b="1" u="none">
                 <a:solidFill>
                   <a:srgbClr val="FFFFFF"/>
                 </a:solidFill>
                 <a:latin typeface="Arial"/>
               </a:rPr>
-              <a:t>Strategies to overcome</a:t>
+              <a:t>Strategies for overcoming these challenges</a:t>
             </a:r>
           </a:p>
         </p:txBody>
@@ -8036,7 +7990,7 @@
                 </a:solidFill>
                 <a:latin typeface="Arial"/>
               </a:rPr>
-              <a:t>Benefits of the solution</a:t>
+              <a:t>Benefits of the solution (social, economic, environmental)</a:t>
             </a:r>
           </a:p>
         </p:txBody>
@@ -8960,8 +8914,8 @@
         </p:nvSpPr>
         <p:spPr>
           <a:xfrm>
-            <a:off x="508000" y="1625600"/>
-            <a:ext cx="10160000" cy="508000"/>
+            <a:off x="508000" y="1498600"/>
+            <a:ext cx="10922000" cy="508000"/>
           </a:xfrm>
           <a:prstGeom prst="rect">
             <a:avLst/>
@@ -8976,7 +8930,7 @@
           <a:p>
             <a:pPr algn="l"/>
             <a:r>
-              <a:rPr sz="2100" b="1" u="none">
+              <a:rPr sz="2200" b="1" u="none">
                 <a:solidFill>
                   <a:srgbClr val="1F4E8C"/>
                 </a:solidFill>
@@ -8985,13 +8939,13 @@
               <a:t>• </a:t>
             </a:r>
             <a:r>
-              <a:rPr sz="2100" b="1" u="sng">
+              <a:rPr sz="2200" b="1" u="sng">
                 <a:solidFill>
                   <a:srgbClr val="1F4E8C"/>
                 </a:solidFill>
                 <a:latin typeface="Arial"/>
               </a:rPr>
-              <a:t>Problem &amp; domain</a:t>
+              <a:t>Details / Links of the reference and research work</a:t>
             </a:r>
           </a:p>
         </p:txBody>
@@ -9004,7 +8958,42 @@
         </p:nvSpPr>
         <p:spPr>
           <a:xfrm>
-            <a:off x="762000" y="2108200"/>
+            <a:off x="762000" y="2095500"/>
+            <a:ext cx="10160000" cy="431800"/>
+          </a:xfrm>
+          <a:prstGeom prst="rect">
+            <a:avLst/>
+          </a:prstGeom>
+          <a:noFill/>
+        </p:spPr>
+        <p:txBody>
+          <a:bodyPr wrap="square" anchor="t" lIns="25400" rIns="25400" tIns="25400" bIns="25400">
+            <a:spAutoFit/>
+          </a:bodyPr>
+          <a:lstStyle/>
+          <a:p>
+            <a:pPr algn="l"/>
+            <a:r>
+              <a:rPr sz="1900" b="1" u="none">
+                <a:solidFill>
+                  <a:srgbClr val="1E1E1E"/>
+                </a:solidFill>
+                <a:latin typeface="Arial"/>
+              </a:rPr>
+              <a:t>Problem &amp; domain</a:t>
+            </a:r>
+          </a:p>
+        </p:txBody>
+      </p:sp>
+      <p:sp>
+        <p:nvSpPr>
+          <p:cNvPr id="11" name="TextBox 10"/>
+          <p:cNvSpPr txBox="1"/>
+          <p:nvPr/>
+        </p:nvSpPr>
+        <p:spPr>
+          <a:xfrm>
+            <a:off x="762000" y="2578100"/>
             <a:ext cx="10541000" cy="1524000"/>
           </a:xfrm>
           <a:prstGeom prst="rect">
@@ -9096,14 +9085,14 @@
       </p:sp>
       <p:sp>
         <p:nvSpPr>
-          <p:cNvPr id="11" name="TextBox 10"/>
+          <p:cNvPr id="12" name="TextBox 11"/>
           <p:cNvSpPr txBox="1"/>
           <p:nvPr/>
         </p:nvSpPr>
         <p:spPr>
           <a:xfrm>
-            <a:off x="508000" y="3403600"/>
-            <a:ext cx="10160000" cy="508000"/>
+            <a:off x="762000" y="3873500"/>
+            <a:ext cx="10160000" cy="431800"/>
           </a:xfrm>
           <a:prstGeom prst="rect">
             <a:avLst/>
@@ -9118,18 +9107,9 @@
           <a:p>
             <a:pPr algn="l"/>
             <a:r>
-              <a:rPr sz="2100" b="1" u="none">
-                <a:solidFill>
-                  <a:srgbClr val="1F4E8C"/>
-                </a:solidFill>
-                <a:latin typeface="Arial"/>
-              </a:rPr>
-              <a:t>• </a:t>
-            </a:r>
-            <a:r>
-              <a:rPr sz="2100" b="1" u="sng">
-                <a:solidFill>
-                  <a:srgbClr val="1F4E8C"/>
+              <a:rPr sz="1900" b="1" u="none">
+                <a:solidFill>
+                  <a:srgbClr val="1E1E1E"/>
                 </a:solidFill>
                 <a:latin typeface="Arial"/>
               </a:rPr>
@@ -9140,13 +9120,13 @@
       </p:sp>
       <p:sp>
         <p:nvSpPr>
-          <p:cNvPr id="12" name="TextBox 11"/>
+          <p:cNvPr id="13" name="TextBox 12"/>
           <p:cNvSpPr txBox="1"/>
           <p:nvPr/>
         </p:nvSpPr>
         <p:spPr>
           <a:xfrm>
-            <a:off x="762000" y="3886200"/>
+            <a:off x="762000" y="4356100"/>
             <a:ext cx="10541000" cy="3556000"/>
           </a:xfrm>
           <a:prstGeom prst="rect">
@@ -9338,14 +9318,14 @@
       </p:sp>
       <p:sp>
         <p:nvSpPr>
-          <p:cNvPr id="13" name="TextBox 12"/>
+          <p:cNvPr id="14" name="TextBox 13"/>
           <p:cNvSpPr txBox="1"/>
           <p:nvPr/>
         </p:nvSpPr>
         <p:spPr>
           <a:xfrm>
-            <a:off x="508000" y="6400800"/>
-            <a:ext cx="10160000" cy="508000"/>
+            <a:off x="762000" y="6870700"/>
+            <a:ext cx="10160000" cy="431800"/>
           </a:xfrm>
           <a:prstGeom prst="rect">
             <a:avLst/>
@@ -9360,18 +9340,9 @@
           <a:p>
             <a:pPr algn="l"/>
             <a:r>
-              <a:rPr sz="2100" b="1" u="none">
-                <a:solidFill>
-                  <a:srgbClr val="1F4E8C"/>
-                </a:solidFill>
-                <a:latin typeface="Arial"/>
-              </a:rPr>
-              <a:t>• </a:t>
-            </a:r>
-            <a:r>
-              <a:rPr sz="2100" b="1" u="sng">
-                <a:solidFill>
-                  <a:srgbClr val="1F4E8C"/>
+              <a:rPr sz="1900" b="1" u="none">
+                <a:solidFill>
+                  <a:srgbClr val="1E1E1E"/>
                 </a:solidFill>
                 <a:latin typeface="Arial"/>
               </a:rPr>
@@ -9382,13 +9353,13 @@
       </p:sp>
       <p:sp>
         <p:nvSpPr>
-          <p:cNvPr id="14" name="TextBox 13"/>
+          <p:cNvPr id="15" name="TextBox 14"/>
           <p:cNvSpPr txBox="1"/>
           <p:nvPr/>
         </p:nvSpPr>
         <p:spPr>
           <a:xfrm>
-            <a:off x="762000" y="6883400"/>
+            <a:off x="762000" y="7353300"/>
             <a:ext cx="10541000" cy="508000"/>
           </a:xfrm>
           <a:prstGeom prst="rect">
@@ -9430,7 +9401,7 @@
       </p:sp>
       <p:sp>
         <p:nvSpPr>
-          <p:cNvPr id="15" name="Rounded Rectangle 14"/>
+          <p:cNvPr id="16" name="Rounded Rectangle 15"/>
           <p:cNvSpPr/>
           <p:nvPr/>
         </p:nvSpPr>
@@ -9474,30 +9445,6 @@
           </a:p>
         </p:txBody>
       </p:sp>
-      <p:pic>
-        <p:nvPicPr>
-          <p:cNvPr id="16" name="Picture 15" descr="logo.png"/>
-          <p:cNvPicPr>
-            <a:picLocks noChangeAspect="1"/>
-          </p:cNvPicPr>
-          <p:nvPr/>
-        </p:nvPicPr>
-        <p:blipFill>
-          <a:blip r:embed="rId3"/>
-          <a:stretch>
-            <a:fillRect/>
-          </a:stretch>
-        </p:blipFill>
-        <p:spPr>
-          <a:xfrm>
-            <a:off x="13779500" y="2032000"/>
-            <a:ext cx="2032000" cy="2032000"/>
-          </a:xfrm>
-          <a:prstGeom prst="rect">
-            <a:avLst/>
-          </a:prstGeom>
-        </p:spPr>
-      </p:pic>
       <p:sp>
         <p:nvSpPr>
           <p:cNvPr id="17" name="TextBox 16"/>
@@ -9506,8 +9453,8 @@
         </p:nvSpPr>
         <p:spPr>
           <a:xfrm>
-            <a:off x="12065000" y="4254500"/>
-            <a:ext cx="5461000" cy="4953000"/>
+            <a:off x="12065000" y="1905000"/>
+            <a:ext cx="5461000" cy="7112000"/>
           </a:xfrm>
           <a:prstGeom prst="rect">
             <a:avLst/>

</xml_diff>